<commit_message>
Propagate corrected numbers everywhere; review notes for Rutu
- README: corrected counts throughout, new 4.8 (missing-code bug),
  results 9.1-9.8 rebuilt on corrected data (26 features), conformal
  and transition sections with known issues, label-fragility findings,
  updated status/next steps/limitations, decisions 19-20
- docs: preprocessing methods (new 5b), transition design, model card,
  proposals trace, architecture, clinical need, conformal, orchestrator,
  config.yaml
- dataset_figures.py now computes every number from the data; both
  figures regenerated
- paper v7: section 5 numbers corrected, missing-data-codes paragraph,
  GENETIC_COHORT marked excluded
- slides: slides 8, 10, 11 corrected; slide-10 figure replaced
- HANDOFF_README: stale-results banner
- docs/NEXT_STEPS_RUTU.md: ordered fix list from the 28 Sep review
</commit_message>
<xml_diff>
--- a/reports/slides/TRACE-PD_first_review.pptx
+++ b/reports/slides/TRACE-PD_first_review.pptx
@@ -3752,44 +3752,6 @@
           </a:p>
         </p:txBody>
       </p:sp>
-      <p:pic>
-        <p:nvPicPr>
-          <p:cNvPr id="5" name="image1.png">
-            <a:extLst>
-              <a:ext uri="{FF2B5EF4-FFF2-40B4-BE49-F238E27FC236}">
-                <a16:creationId xmlns:a16="http://schemas.microsoft.com/office/drawing/2014/main" id="{241EA872-45FE-4F3A-C23B-9BCCD63081EF}"/>
-              </a:ext>
-            </a:extLst>
-          </p:cNvPr>
-          <p:cNvPicPr>
-            <a:picLocks noGrp="1"/>
-          </p:cNvPicPr>
-          <p:nvPr>
-            <p:ph idx="1"/>
-          </p:nvPr>
-        </p:nvPicPr>
-        <p:blipFill>
-          <a:blip r:embed="rId2"/>
-          <a:srcRect/>
-          <a:stretch>
-            <a:fillRect/>
-          </a:stretch>
-        </p:blipFill>
-        <p:spPr>
-          <a:xfrm>
-            <a:off x="1200000" y="1143000"/>
-            <a:ext cx="9800000" cy="3150000"/>
-          </a:xfrm>
-          <a:prstGeom prst="rect">
-            <a:avLst/>
-          </a:prstGeom>
-          <a:ln>
-            <a:solidFill>
-              <a:schemeClr val="tx1"/>
-            </a:solidFill>
-          </a:ln>
-        </p:spPr>
-      </p:pic>
       <p:sp>
         <p:nvSpPr>
           <p:cNvPr id="7" name="TextBox 6">
@@ -3838,25 +3800,25 @@
               <a:rPr lang="en-IN" dirty="0" sz="1400">
                 <a:latin typeface="Times New Roman"/>
               </a:rPr>
-              <a:t> 439 patients → visits joined → 5,742 </a:t>
+              <a:t> 439 patients → visits joined → 5,638 labeled visit-rows (18.5% unlabeled</a:t>
             </a:r>
             <a:r>
               <a:rPr lang="en-IN" dirty="0" err="1" sz="1400">
                 <a:latin typeface="Times New Roman"/>
               </a:rPr>
-              <a:t>labeled</a:t>
+              <a:t/>
             </a:r>
             <a:r>
               <a:rPr lang="en-IN" dirty="0" sz="1400">
                 <a:latin typeface="Times New Roman"/>
               </a:rPr>
-              <a:t> visit-rows (17% </a:t>
+              <a:t/>
             </a:r>
             <a:r>
               <a:rPr lang="en-IN" dirty="0" err="1" sz="1400">
                 <a:latin typeface="Times New Roman"/>
               </a:rPr>
-              <a:t>unlabeled</a:t>
+              <a:t/>
             </a:r>
             <a:r>
               <a:rPr lang="en-IN" dirty="0" sz="1400">
@@ -3886,7 +3848,7 @@
               <a:rPr lang="en-IN" dirty="0" sz="1400">
                 <a:latin typeface="Times New Roman"/>
               </a:rPr>
-              <a:t> TD 52.6% / PIGD 36.6% / Indeterminate 10.8%</a:t>
+              <a:t> TD 53.5% / PIGD 35.5% / Indeterminate 11.0%</a:t>
             </a:r>
           </a:p>
           <a:p>
@@ -3910,23 +3872,47 @@
               <a:rPr lang="en-IN" dirty="0" sz="1400">
                 <a:latin typeface="Times New Roman"/>
               </a:rPr>
-              <a:t> 355 of 439 patients (</a:t>
+              <a:t> 344 of 439 patients (78.4%)</a:t>
             </a:r>
             <a:r>
               <a:rPr lang="en-IN" b="1" dirty="0" sz="1400">
                 <a:latin typeface="Times New Roman"/>
               </a:rPr>
-              <a:t>80.9%</a:t>
+              <a:t/>
             </a:r>
             <a:r>
               <a:rPr lang="en-IN" dirty="0" sz="1400">
                 <a:latin typeface="Times New Roman"/>
               </a:rPr>
-              <a:t>) change label at least once across visits — corroborates the 33–50% reclassification range reported in the literature; Indeterminate is the least stable class</a:t>
-            </a:r>
-          </a:p>
-        </p:txBody>
-      </p:sp>
+              <a:t> change label at least once across visits — corroborates the 33–50% reclassification range reported in the literature; Indeterminate is the least stable class</a:t>
+            </a:r>
+          </a:p>
+        </p:txBody>
+      </p:sp>
+      <p:pic>
+        <p:nvPicPr>
+          <p:cNvPr id="8" name="Picture 7" descr="fig_cohort_labels.png"/>
+          <p:cNvPicPr>
+            <a:picLocks noChangeAspect="1"/>
+          </p:cNvPicPr>
+          <p:nvPr/>
+        </p:nvPicPr>
+        <p:blipFill>
+          <a:blip r:embed="rId3"/>
+          <a:stretch>
+            <a:fillRect/>
+          </a:stretch>
+        </p:blipFill>
+        <p:spPr>
+          <a:xfrm>
+            <a:off x="1200000" y="1133718"/>
+            <a:ext cx="9800000" cy="3168564"/>
+          </a:xfrm>
+          <a:prstGeom prst="rect">
+            <a:avLst/>
+          </a:prstGeom>
+        </p:spPr>
+      </p:pic>
     </p:spTree>
     <p:extLst>
       <p:ext uri="{BB962C8B-B14F-4D97-AF65-F5344CB8AC3E}">
@@ -4333,21 +4319,21 @@
                 <a:latin typeface="Times New Roman" panose="02020603050405020304" pitchFamily="18" charset="0"/>
                 <a:cs typeface="Times New Roman" panose="02020603050405020304" pitchFamily="18" charset="0"/>
               </a:rPr>
-              <a:t> → TD if tremor &gt; 0, else Indeterminate (845 rows, 14.7% of </a:t>
+              <a:t> → TD if tremor &gt; 0, else Indeterminate (845 rows, 15.0% of labeled rows)</a:t>
             </a:r>
             <a:r>
               <a:rPr lang="en-IN" sz="1350" dirty="0" err="1">
                 <a:latin typeface="Times New Roman" panose="02020603050405020304" pitchFamily="18" charset="0"/>
                 <a:cs typeface="Times New Roman" panose="02020603050405020304" pitchFamily="18" charset="0"/>
               </a:rPr>
-              <a:t>labeled</a:t>
+              <a:t/>
             </a:r>
             <a:r>
               <a:rPr lang="en-IN" sz="1350" dirty="0">
                 <a:latin typeface="Times New Roman" panose="02020603050405020304" pitchFamily="18" charset="0"/>
                 <a:cs typeface="Times New Roman" panose="02020603050405020304" pitchFamily="18" charset="0"/>
               </a:rPr>
-              <a:t> rows)</a:t>
+              <a:t/>
             </a:r>
             <a:endParaRPr lang="en-IN" sz="1800" b="1" dirty="0">
               <a:latin typeface="Times New Roman" panose="02020603050405020304" pitchFamily="18" charset="0"/>
@@ -4375,21 +4361,21 @@
                 <a:latin typeface="Times New Roman" panose="02020603050405020304" pitchFamily="18" charset="0"/>
                 <a:cs typeface="Times New Roman" panose="02020603050405020304" pitchFamily="18" charset="0"/>
               </a:rPr>
-              <a:t> — label only assigned when all 16 items are present (17% of visit-rows remain </a:t>
+              <a:t> — label only assigned when all 16 items are present (18.5% of visit-rows remain unlabeled)</a:t>
             </a:r>
             <a:r>
               <a:rPr lang="en-IN" sz="1350" dirty="0" err="1">
                 <a:latin typeface="Times New Roman" panose="02020603050405020304" pitchFamily="18" charset="0"/>
                 <a:cs typeface="Times New Roman" panose="02020603050405020304" pitchFamily="18" charset="0"/>
               </a:rPr>
-              <a:t>unlabeled</a:t>
+              <a:t/>
             </a:r>
             <a:r>
               <a:rPr lang="en-IN" sz="1350" dirty="0">
                 <a:latin typeface="Times New Roman" panose="02020603050405020304" pitchFamily="18" charset="0"/>
                 <a:cs typeface="Times New Roman" panose="02020603050405020304" pitchFamily="18" charset="0"/>
               </a:rPr>
-              <a:t>)</a:t>
+              <a:t/>
             </a:r>
             <a:endParaRPr lang="en-IN" sz="1800" b="1" dirty="0">
               <a:latin typeface="Times New Roman" panose="02020603050405020304" pitchFamily="18" charset="0"/>
@@ -4439,21 +4425,21 @@
                 <a:latin typeface="Times New Roman" panose="02020603050405020304" pitchFamily="18" charset="0"/>
                 <a:cs typeface="Times New Roman" panose="02020603050405020304" pitchFamily="18" charset="0"/>
               </a:rPr>
-              <a:t> — every label independently recomputed from its two component scores across all 5,742 </a:t>
+              <a:t> — every label independently recomputed from its two component scores across all 5,638 labeled rows</a:t>
             </a:r>
             <a:r>
               <a:rPr lang="en-IN" sz="1350" dirty="0" err="1">
                 <a:latin typeface="Times New Roman" panose="02020603050405020304" pitchFamily="18" charset="0"/>
                 <a:cs typeface="Times New Roman" panose="02020603050405020304" pitchFamily="18" charset="0"/>
               </a:rPr>
-              <a:t>labeled</a:t>
+              <a:t/>
             </a:r>
             <a:r>
               <a:rPr lang="en-IN" sz="1350" dirty="0">
                 <a:latin typeface="Times New Roman" panose="02020603050405020304" pitchFamily="18" charset="0"/>
                 <a:cs typeface="Times New Roman" panose="02020603050405020304" pitchFamily="18" charset="0"/>
               </a:rPr>
-              <a:t> rows</a:t>
+              <a:t/>
             </a:r>
             <a:br>
               <a:rPr lang="en-IN" sz="1800" dirty="0">
@@ -9448,21 +9434,21 @@
                 <a:latin typeface="Times New Roman" panose="02020603050405020304" pitchFamily="18" charset="0"/>
                 <a:cs typeface="Times New Roman" panose="02020603050405020304" pitchFamily="18" charset="0"/>
               </a:rPr>
-              <a:t> across all 5,742 </a:t>
+              <a:t> across all 5,638 labeled rows</a:t>
             </a:r>
             <a:r>
               <a:rPr lang="en-IN" sz="1350" dirty="0" err="1">
                 <a:latin typeface="Times New Roman" panose="02020603050405020304" pitchFamily="18" charset="0"/>
                 <a:cs typeface="Times New Roman" panose="02020603050405020304" pitchFamily="18" charset="0"/>
               </a:rPr>
-              <a:t>labeled</a:t>
+              <a:t/>
             </a:r>
             <a:r>
               <a:rPr lang="en-IN" sz="1350" dirty="0">
                 <a:latin typeface="Times New Roman" panose="02020603050405020304" pitchFamily="18" charset="0"/>
                 <a:cs typeface="Times New Roman" panose="02020603050405020304" pitchFamily="18" charset="0"/>
               </a:rPr>
-              <a:t> rows when every label was independently recomputed</a:t>
+              <a:t> when every label was independently recomputed</a:t>
             </a:r>
             <a:endParaRPr lang="en-IN" sz="1800" b="1" dirty="0">
               <a:latin typeface="Times New Roman" panose="02020603050405020304" pitchFamily="18" charset="0"/>

</xml_diff>